<commit_message>
Deck: point closing slide at renamed repo
Co-Authored-By: Claude Opus 5.5 <noreply@anthropic.com>
</commit_message>
<xml_diff>
--- a/SynapseGrid-Proposal.pptx
+++ b/SynapseGrid-Proposal.pptx
@@ -119,23 +119,23 @@
   <p:extLst>
     <p:ext uri="{521415D9-36F7-43E2-AB2F-B90AF26B5E84}">
       <p14:sectionLst xmlns:p14="http://schemas.microsoft.com/office/powerpoint/2010/main">
-        <p14:section name="Introduction" id="{41f82128-06bd-6e47-a400-6cfff684c6ec}">
+        <p14:section name="Introduction" id="{0060d099-a166-898d-989c-f05389987e5f}">
           <p14:sldIdLst>
             <p14:sldId id="256"/>
           </p14:sldIdLst>
         </p14:section>
-        <p14:section name="Problem" id="{686aa57c-9346-c14c-4513-2ff7354daeb8}">
+        <p14:section name="Problem" id="{65d5140b-03e1-382c-1a4e-d5d5d23c975b}">
           <p14:sldIdLst>
             <p14:sldId id="257"/>
           </p14:sldIdLst>
         </p14:section>
-        <p14:section name="Solution" id="{a52a9a0d-1db7-bd05-e637-a0f7b359fc0a}">
+        <p14:section name="Solution" id="{13acb699-bbb1-92a4-4555-5e7f1da3692d}">
           <p14:sldIdLst>
             <p14:sldId id="258"/>
             <p14:sldId id="259"/>
           </p14:sldIdLst>
         </p14:section>
-        <p14:section name="Impact" id="{6cce2364-f1cd-c222-18b9-4364cfa8f206}">
+        <p14:section name="Impact" id="{853b9277-ff2b-64d3-90e0-522c1b5f407d}">
           <p14:sldIdLst>
             <p14:sldId id="260"/>
             <p14:sldId id="261"/>
@@ -143,13 +143,13 @@
             <p14:sldId id="263"/>
           </p14:sldIdLst>
         </p14:section>
-        <p14:section name="Technology" id="{8751404d-ac01-8d14-4006-6979f132c992}">
+        <p14:section name="Technology" id="{833519be-ff74-9524-28a1-92b179a2316b}">
           <p14:sldIdLst>
             <p14:sldId id="264"/>
             <p14:sldId id="265"/>
           </p14:sldIdLst>
         </p14:section>
-        <p14:section name="Outlook" id="{a7b417d8-8f55-e261-cbbe-766fbeb6201d}">
+        <p14:section name="Outlook" id="{fd4f5165-1d76-b50f-dec4-5d6d062e7930}">
           <p14:sldIdLst>
             <p14:sldId id="266"/>
             <p14:sldId id="267"/>
@@ -5446,7 +5446,7 @@
                   <a:schemeClr val="bg2"/>
                 </a:solidFill>
               </a:rPr>
-              <a:t>github.com/souzataniya/Medical</a:t>
+              <a:t>github.com/souzataniya/SynapseGrid</a:t>
             </a:r>
             <a:endParaRPr lang="en-US" sz="1400" dirty="0"/>
           </a:p>

</xml_diff>

<commit_message>
Gemma 4 support, verified live: skip thought parts, minimal thinking, JSON mode, retry without unsupported thinking config
- default model gemma-4-26b-a4b-it (Gemma 3 ids are not offered to new AI Studio keys)
- briefing facts rounded to 3 dp; prompt forbids unchecked trend claims
- docs and deck updated with live results

Co-Authored-By: Claude Opus 5.5 <noreply@anthropic.com>
</commit_message>
<xml_diff>
--- a/SynapseGrid-Proposal.pptx
+++ b/SynapseGrid-Proposal.pptx
@@ -119,23 +119,23 @@
   <p:extLst>
     <p:ext uri="{521415D9-36F7-43E2-AB2F-B90AF26B5E84}">
       <p14:sectionLst xmlns:p14="http://schemas.microsoft.com/office/powerpoint/2010/main">
-        <p14:section name="Introduction" id="{0060d099-a166-898d-989c-f05389987e5f}">
+        <p14:section name="Introduction" id="{69207f8d-1feb-b71b-f89a-760ca3162d33}">
           <p14:sldIdLst>
             <p14:sldId id="256"/>
           </p14:sldIdLst>
         </p14:section>
-        <p14:section name="Problem" id="{65d5140b-03e1-382c-1a4e-d5d5d23c975b}">
+        <p14:section name="Problem" id="{7779346c-9382-d8d3-5cb8-d4bfbb76533f}">
           <p14:sldIdLst>
             <p14:sldId id="257"/>
           </p14:sldIdLst>
         </p14:section>
-        <p14:section name="Solution" id="{13acb699-bbb1-92a4-4555-5e7f1da3692d}">
+        <p14:section name="Solution" id="{9c94a1cb-ba5e-3d33-fb4a-fc3f7b41ce0e}">
           <p14:sldIdLst>
             <p14:sldId id="258"/>
             <p14:sldId id="259"/>
           </p14:sldIdLst>
         </p14:section>
-        <p14:section name="Impact" id="{853b9277-ff2b-64d3-90e0-522c1b5f407d}">
+        <p14:section name="Impact" id="{fbe2b4ef-e590-e637-b64d-46ac85d98560}">
           <p14:sldIdLst>
             <p14:sldId id="260"/>
             <p14:sldId id="261"/>
@@ -143,13 +143,13 @@
             <p14:sldId id="263"/>
           </p14:sldIdLst>
         </p14:section>
-        <p14:section name="Technology" id="{833519be-ff74-9524-28a1-92b179a2316b}">
+        <p14:section name="Technology" id="{08df16e4-057e-bb1d-a73d-3b63596bb9c4}">
           <p14:sldIdLst>
             <p14:sldId id="264"/>
             <p14:sldId id="265"/>
           </p14:sldIdLst>
         </p14:section>
-        <p14:section name="Outlook" id="{fd4f5165-1d76-b50f-dec4-5d6d062e7930}">
+        <p14:section name="Outlook" id="{c3c903c0-3d4f-6bd7-8a80-4691b7ccde47}">
           <p14:sldIdLst>
             <p14:sldId id="266"/>
             <p14:sldId id="267"/>
@@ -1907,7 +1907,7 @@
           <a:p>
             <a:r>
               <a:rPr lang="en-US" dirty="0"/>
-              <a:t>Gemma does the part machines are traditionally bad at: reading messy human context. The structured, validated output keeps it from becoming a safety risk. Tested so far against mocked responses; a live run needs an API key.</a:t>
+              <a:t>Gemma does the part machines are traditionally bad at: reading messy human context. The structured, validated output keeps it from becoming a safety risk. Verified live with gemma-4-26b-a4b-it via Google AI Studio: about 6 seconds per interpretation.</a:t>
             </a:r>
             <a:endParaRPr lang="en-US" dirty="0"/>
           </a:p>
@@ -3454,7 +3454,7 @@
                   <a:schemeClr val="accent1"/>
                 </a:solidFill>
               </a:rPr>
-              <a:t>35</a:t>
+              <a:t>36</a:t>
             </a:r>
             <a:endParaRPr lang="en-US" sz="3000" dirty="0"/>
           </a:p>
@@ -4722,7 +4722,7 @@
                   <a:schemeClr val="tx1"/>
                 </a:solidFill>
               </a:rPr>
-              <a:t>Tested: 35 automated tests plus a 300-scenario randomized evaluation</a:t>
+              <a:t>Tested: 36 automated tests, a 300-scenario randomized evaluation, and live Gemma 4 calls</a:t>
             </a:r>
             <a:endParaRPr lang="en-US" sz="1500" dirty="0"/>
           </a:p>
@@ -4918,7 +4918,7 @@
                   <a:schemeClr val="tx1"/>
                 </a:solidFill>
               </a:rPr>
-              <a:t>Tested against a live Gemma endpoint — only mocked responses so far</a:t>
+              <a:t>Instant at the AI step — a live Gemma call takes several seconds, while planning and checking take under 1 ms</a:t>
             </a:r>
             <a:endParaRPr lang="en-US" sz="1500" dirty="0"/>
           </a:p>

</xml_diff>

<commit_message>
Add narrated 3-minute demo video; fix renewable share >100% when batteries charge
- renewable share is now renewables / total supply (battery charging is a sink), so it cannot exceed 100%
- Gemma panel shows retried transient errors as a muted note instead of red errors
- refreshed screenshots, GIF and deck with corrected numbers
- docs/video: SynapseGrid-Demo.mp4 (live prototype + real Gemma 4 call, Gemini TTS narration) and narration script

Co-Authored-By: Claude Opus 5.5 <noreply@anthropic.com>
</commit_message>
<xml_diff>
--- a/SynapseGrid-Proposal.pptx
+++ b/SynapseGrid-Proposal.pptx
@@ -119,23 +119,23 @@
   <p:extLst>
     <p:ext uri="{521415D9-36F7-43E2-AB2F-B90AF26B5E84}">
       <p14:sectionLst xmlns:p14="http://schemas.microsoft.com/office/powerpoint/2010/main">
-        <p14:section name="Introduction" id="{69207f8d-1feb-b71b-f89a-760ca3162d33}">
+        <p14:section name="Introduction" id="{198ce388-8990-ab52-e5d5-8fd7faf93887}">
           <p14:sldIdLst>
             <p14:sldId id="256"/>
           </p14:sldIdLst>
         </p14:section>
-        <p14:section name="Problem" id="{7779346c-9382-d8d3-5cb8-d4bfbb76533f}">
+        <p14:section name="Problem" id="{a4285741-285f-b2fe-c7c6-845e3941e04f}">
           <p14:sldIdLst>
             <p14:sldId id="257"/>
           </p14:sldIdLst>
         </p14:section>
-        <p14:section name="Solution" id="{9c94a1cb-ba5e-3d33-fb4a-fc3f7b41ce0e}">
+        <p14:section name="Solution" id="{a2d20d67-2214-4415-5785-f046b906ed34}">
           <p14:sldIdLst>
             <p14:sldId id="258"/>
             <p14:sldId id="259"/>
           </p14:sldIdLst>
         </p14:section>
-        <p14:section name="Impact" id="{fbe2b4ef-e590-e637-b64d-46ac85d98560}">
+        <p14:section name="Impact" id="{eba5d3e6-e9ad-935b-c687-908a0757c051}">
           <p14:sldIdLst>
             <p14:sldId id="260"/>
             <p14:sldId id="261"/>
@@ -143,13 +143,13 @@
             <p14:sldId id="263"/>
           </p14:sldIdLst>
         </p14:section>
-        <p14:section name="Technology" id="{08df16e4-057e-bb1d-a73d-3b63596bb9c4}">
+        <p14:section name="Technology" id="{c8eba889-b35a-beaf-f141-ca9b207bdcd4}">
           <p14:sldIdLst>
             <p14:sldId id="264"/>
             <p14:sldId id="265"/>
           </p14:sldIdLst>
         </p14:section>
-        <p14:section name="Outlook" id="{c3c903c0-3d4f-6bd7-8a80-4691b7ccde47}">
+        <p14:section name="Outlook" id="{02ee61ea-b95b-e275-7d6a-deb9f06da6e4}">
           <p14:sldIdLst>
             <p14:sldId id="266"/>
             <p14:sldId id="267"/>

</xml_diff>